<commit_message>
Parallelize eval runner; fix per-slice skill loading; update handoff
The runner was injecting all six SKILL.md bodies into every question
(11,253 tokens against a 17-token ask), which measured context dilution
rather than skill quality. Skills mode now loads only the skill under
test per slice; --load-all preserves the old all-skills behavior since
that contrast is itself a finding. Adds --workers and --max-turns.
</commit_message>
<xml_diff>
--- a/vibe-analytics-workshop.pptx
+++ b/vibe-analytics-workshop.pptx
@@ -781,7 +781,7 @@
           <a:p>
             <a:r>
               <a:rPr lang="en-US" dirty="0"/>
-              <a:t>Do not hide this. A negative first result, investigated rather than buried, is a better story than a clean win — and it is the discipline we are teaching. Ask the room what they would check first.</a:t>
+              <a:t>Lead with the number, then immediately give the caveats on the next slide. The mean and median agree (+28.2 / +27.8), so it is not one outlier carrying the result. Say plainly that this is one run by the people who wrote the skills.</a:t>
             </a:r>
             <a:endParaRPr lang="en-US" dirty="0"/>
           </a:p>
@@ -869,7 +869,7 @@
           <a:p>
             <a:r>
               <a:rPr lang="en-US" dirty="0"/>
-              <a:t>This is the most valuable finding in the project. The room will arrive assuming the hard part is writing good instructions. The data says the hard part is routing — getting the right instructions to the right question and keeping the rest out. That is the argument for a thin router plus reference docs that load on demand.</a:t>
+              <a:t>This slide is the point of the workshop. Anyone can report +28. Reporting +28 alongside the over-firing cost, the non-random missing data, and a sensitivity analysis is what makes it trustworthy. Note that the censoring problem here is exactly pattern 2 in analysis-patterns.md — we hit it in our own measurement.</a:t>
             </a:r>
             <a:endParaRPr lang="en-US" dirty="0"/>
           </a:p>
@@ -4013,7 +4013,7 @@
                 <a:ea typeface="Cambria" pitchFamily="34" charset="-122"/>
                 <a:cs typeface="Cambria" pitchFamily="34" charset="-120"/>
               </a:rPr>
-              <a:t>The first full run came back negative</a:t>
+              <a:t>56% to 84%, across every slice</a:t>
             </a:r>
             <a:endParaRPr lang="en-US" sz="3400" dirty="0"/>
           </a:p>
@@ -4027,12 +4027,12 @@
         </p:nvSpPr>
         <p:spPr>
           <a:xfrm>
-            <a:off x="640080" y="1828800"/>
-            <a:ext cx="5074920" cy="1920240"/>
+            <a:off x="640080" y="1600200"/>
+            <a:ext cx="10908792" cy="548640"/>
           </a:xfrm>
           <a:prstGeom prst="roundRect">
             <a:avLst>
-              <a:gd name="adj" fmla="val 3810"/>
+              <a:gd name="adj" fmla="val 13333"/>
             </a:avLst>
           </a:prstGeom>
           <a:solidFill>
@@ -4054,63 +4054,324 @@
         </p:nvSpPr>
         <p:spPr>
           <a:xfrm>
-            <a:off x="960120" y="2057400"/>
-            <a:ext cx="4434840" cy="365760"/>
-          </a:xfrm>
-          <a:prstGeom prst="rect">
-            <a:avLst/>
-          </a:prstGeom>
-          <a:noFill/>
-          <a:ln/>
-        </p:spPr>
-        <p:txBody>
-          <a:bodyPr wrap="square" lIns="0" tIns="0" rIns="0" bIns="0" rtlCol="0" anchor="ctr"/>
-          <a:lstStyle/>
-          <a:p>
-            <a:pPr indent="0" marL="0">
-              <a:buNone/>
-            </a:pPr>
-            <a:r>
-              <a:rPr lang="en-US" sz="1700" b="1" dirty="0">
+            <a:off x="960120" y="1719072"/>
+            <a:ext cx="4754880" cy="320040"/>
+          </a:xfrm>
+          <a:prstGeom prst="rect">
+            <a:avLst/>
+          </a:prstGeom>
+          <a:noFill/>
+          <a:ln/>
+        </p:spPr>
+        <p:txBody>
+          <a:bodyPr wrap="square" lIns="0" tIns="0" rIns="0" bIns="0" rtlCol="0" anchor="ctr"/>
+          <a:lstStyle/>
+          <a:p>
+            <a:pPr indent="0" marL="0">
+              <a:buNone/>
+            </a:pPr>
+            <a:r>
+              <a:rPr lang="en-US" sz="1400" dirty="0">
                 <a:solidFill>
                   <a:srgbClr val="CBD5DD"/>
+                </a:solidFill>
+                <a:latin typeface="Consolas" pitchFamily="34" charset="0"/>
+                <a:ea typeface="Consolas" pitchFamily="34" charset="-122"/>
+                <a:cs typeface="Consolas" pitchFamily="34" charset="-120"/>
+              </a:rPr>
+              <a:t>uncertainty-reporting</a:t>
+            </a:r>
+            <a:endParaRPr lang="en-US" sz="1400" dirty="0"/>
+          </a:p>
+        </p:txBody>
+      </p:sp>
+      <p:sp>
+        <p:nvSpPr>
+          <p:cNvPr id="6" name="Text 4"/>
+          <p:cNvSpPr/>
+          <p:nvPr/>
+        </p:nvSpPr>
+        <p:spPr>
+          <a:xfrm>
+            <a:off x="6126480" y="1719072"/>
+            <a:ext cx="1280160" cy="320040"/>
+          </a:xfrm>
+          <a:prstGeom prst="rect">
+            <a:avLst/>
+          </a:prstGeom>
+          <a:noFill/>
+          <a:ln/>
+        </p:spPr>
+        <p:txBody>
+          <a:bodyPr wrap="square" lIns="0" tIns="0" rIns="0" bIns="0" rtlCol="0" anchor="ctr"/>
+          <a:lstStyle/>
+          <a:p>
+            <a:pPr algn="r" indent="0" marL="0">
+              <a:buNone/>
+            </a:pPr>
+            <a:r>
+              <a:rPr lang="en-US" sz="1400" dirty="0">
+                <a:solidFill>
+                  <a:srgbClr val="8A99A8"/>
+                </a:solidFill>
+                <a:latin typeface="Calibri" pitchFamily="34" charset="0"/>
+                <a:ea typeface="Calibri" pitchFamily="34" charset="-122"/>
+                <a:cs typeface="Calibri" pitchFamily="34" charset="-120"/>
+              </a:rPr>
+              <a:t>43%</a:t>
+            </a:r>
+            <a:endParaRPr lang="en-US" sz="1400" dirty="0"/>
+          </a:p>
+        </p:txBody>
+      </p:sp>
+      <p:sp>
+        <p:nvSpPr>
+          <p:cNvPr id="7" name="Text 5"/>
+          <p:cNvSpPr/>
+          <p:nvPr/>
+        </p:nvSpPr>
+        <p:spPr>
+          <a:xfrm>
+            <a:off x="7680960" y="1719072"/>
+            <a:ext cx="1280160" cy="320040"/>
+          </a:xfrm>
+          <a:prstGeom prst="rect">
+            <a:avLst/>
+          </a:prstGeom>
+          <a:noFill/>
+          <a:ln/>
+        </p:spPr>
+        <p:txBody>
+          <a:bodyPr wrap="square" lIns="0" tIns="0" rIns="0" bIns="0" rtlCol="0" anchor="ctr"/>
+          <a:lstStyle/>
+          <a:p>
+            <a:pPr algn="r" indent="0" marL="0">
+              <a:buNone/>
+            </a:pPr>
+            <a:r>
+              <a:rPr lang="en-US" sz="1400" dirty="0">
+                <a:solidFill>
+                  <a:srgbClr val="FFFFFF"/>
+                </a:solidFill>
+                <a:latin typeface="Calibri" pitchFamily="34" charset="0"/>
+                <a:ea typeface="Calibri" pitchFamily="34" charset="-122"/>
+                <a:cs typeface="Calibri" pitchFamily="34" charset="-120"/>
+              </a:rPr>
+              <a:t>93%</a:t>
+            </a:r>
+            <a:endParaRPr lang="en-US" sz="1400" dirty="0"/>
+          </a:p>
+        </p:txBody>
+      </p:sp>
+      <p:sp>
+        <p:nvSpPr>
+          <p:cNvPr id="8" name="Text 6"/>
+          <p:cNvSpPr/>
+          <p:nvPr/>
+        </p:nvSpPr>
+        <p:spPr>
+          <a:xfrm>
+            <a:off x="9418320" y="1709928"/>
+            <a:ext cx="2011680" cy="347472"/>
+          </a:xfrm>
+          <a:prstGeom prst="rect">
+            <a:avLst/>
+          </a:prstGeom>
+          <a:noFill/>
+          <a:ln/>
+        </p:spPr>
+        <p:txBody>
+          <a:bodyPr wrap="square" lIns="0" tIns="0" rIns="0" bIns="0" rtlCol="0" anchor="ctr"/>
+          <a:lstStyle/>
+          <a:p>
+            <a:pPr algn="r" indent="0" marL="0">
+              <a:buNone/>
+            </a:pPr>
+            <a:r>
+              <a:rPr lang="en-US" sz="1600" b="1" dirty="0">
+                <a:solidFill>
+                  <a:srgbClr val="2D8A72"/>
                 </a:solidFill>
                 <a:latin typeface="Cambria" pitchFamily="34" charset="0"/>
                 <a:ea typeface="Cambria" pitchFamily="34" charset="-122"/>
                 <a:cs typeface="Cambria" pitchFamily="34" charset="-120"/>
               </a:rPr>
-              <a:t>One skill loaded</a:t>
-            </a:r>
-            <a:endParaRPr lang="en-US" sz="1700" dirty="0"/>
-          </a:p>
-        </p:txBody>
-      </p:sp>
-      <p:sp>
-        <p:nvSpPr>
-          <p:cNvPr id="6" name="Text 4"/>
-          <p:cNvSpPr/>
-          <p:nvPr/>
-        </p:nvSpPr>
-        <p:spPr>
-          <a:xfrm>
-            <a:off x="960120" y="2514600"/>
-            <a:ext cx="4434840" cy="822960"/>
-          </a:xfrm>
-          <a:prstGeom prst="rect">
-            <a:avLst/>
-          </a:prstGeom>
-          <a:noFill/>
-          <a:ln/>
-        </p:spPr>
-        <p:txBody>
-          <a:bodyPr wrap="square" lIns="0" tIns="0" rIns="0" bIns="0" rtlCol="0" anchor="ctr"/>
-          <a:lstStyle/>
-          <a:p>
-            <a:pPr indent="0" marL="0">
-              <a:buNone/>
-            </a:pPr>
-            <a:r>
-              <a:rPr lang="en-US" sz="4400" b="1" dirty="0">
+              <a:t>+50</a:t>
+            </a:r>
+            <a:endParaRPr lang="en-US" sz="1600" dirty="0"/>
+          </a:p>
+        </p:txBody>
+      </p:sp>
+      <p:sp>
+        <p:nvSpPr>
+          <p:cNvPr id="9" name="Shape 7"/>
+          <p:cNvSpPr/>
+          <p:nvPr/>
+        </p:nvSpPr>
+        <p:spPr>
+          <a:xfrm>
+            <a:off x="640080" y="2203704"/>
+            <a:ext cx="10908792" cy="548640"/>
+          </a:xfrm>
+          <a:prstGeom prst="roundRect">
+            <a:avLst>
+              <a:gd name="adj" fmla="val 13333"/>
+            </a:avLst>
+          </a:prstGeom>
+          <a:solidFill>
+            <a:srgbClr val="22303C"/>
+          </a:solidFill>
+          <a:ln w="12700">
+            <a:solidFill>
+              <a:srgbClr val="22303C"/>
+            </a:solidFill>
+            <a:prstDash val="solid"/>
+          </a:ln>
+        </p:spPr>
+      </p:sp>
+      <p:sp>
+        <p:nvSpPr>
+          <p:cNvPr id="10" name="Text 8"/>
+          <p:cNvSpPr/>
+          <p:nvPr/>
+        </p:nvSpPr>
+        <p:spPr>
+          <a:xfrm>
+            <a:off x="960120" y="2322576"/>
+            <a:ext cx="4754880" cy="320040"/>
+          </a:xfrm>
+          <a:prstGeom prst="rect">
+            <a:avLst/>
+          </a:prstGeom>
+          <a:noFill/>
+          <a:ln/>
+        </p:spPr>
+        <p:txBody>
+          <a:bodyPr wrap="square" lIns="0" tIns="0" rIns="0" bIns="0" rtlCol="0" anchor="ctr"/>
+          <a:lstStyle/>
+          <a:p>
+            <a:pPr indent="0" marL="0">
+              <a:buNone/>
+            </a:pPr>
+            <a:r>
+              <a:rPr lang="en-US" sz="1400" dirty="0">
+                <a:solidFill>
+                  <a:srgbClr val="CBD5DD"/>
+                </a:solidFill>
+                <a:latin typeface="Consolas" pitchFamily="34" charset="0"/>
+                <a:ea typeface="Consolas" pitchFamily="34" charset="-122"/>
+                <a:cs typeface="Consolas" pitchFamily="34" charset="-120"/>
+              </a:rPr>
+              <a:t>provenance-footer</a:t>
+            </a:r>
+            <a:endParaRPr lang="en-US" sz="1400" dirty="0"/>
+          </a:p>
+        </p:txBody>
+      </p:sp>
+      <p:sp>
+        <p:nvSpPr>
+          <p:cNvPr id="11" name="Text 9"/>
+          <p:cNvSpPr/>
+          <p:nvPr/>
+        </p:nvSpPr>
+        <p:spPr>
+          <a:xfrm>
+            <a:off x="6126480" y="2322576"/>
+            <a:ext cx="1280160" cy="320040"/>
+          </a:xfrm>
+          <a:prstGeom prst="rect">
+            <a:avLst/>
+          </a:prstGeom>
+          <a:noFill/>
+          <a:ln/>
+        </p:spPr>
+        <p:txBody>
+          <a:bodyPr wrap="square" lIns="0" tIns="0" rIns="0" bIns="0" rtlCol="0" anchor="ctr"/>
+          <a:lstStyle/>
+          <a:p>
+            <a:pPr algn="r" indent="0" marL="0">
+              <a:buNone/>
+            </a:pPr>
+            <a:r>
+              <a:rPr lang="en-US" sz="1400" dirty="0">
+                <a:solidFill>
+                  <a:srgbClr val="8A99A8"/>
+                </a:solidFill>
+                <a:latin typeface="Calibri" pitchFamily="34" charset="0"/>
+                <a:ea typeface="Calibri" pitchFamily="34" charset="-122"/>
+                <a:cs typeface="Calibri" pitchFamily="34" charset="-120"/>
+              </a:rPr>
+              <a:t>39%</a:t>
+            </a:r>
+            <a:endParaRPr lang="en-US" sz="1400" dirty="0"/>
+          </a:p>
+        </p:txBody>
+      </p:sp>
+      <p:sp>
+        <p:nvSpPr>
+          <p:cNvPr id="12" name="Text 10"/>
+          <p:cNvSpPr/>
+          <p:nvPr/>
+        </p:nvSpPr>
+        <p:spPr>
+          <a:xfrm>
+            <a:off x="7680960" y="2322576"/>
+            <a:ext cx="1280160" cy="320040"/>
+          </a:xfrm>
+          <a:prstGeom prst="rect">
+            <a:avLst/>
+          </a:prstGeom>
+          <a:noFill/>
+          <a:ln/>
+        </p:spPr>
+        <p:txBody>
+          <a:bodyPr wrap="square" lIns="0" tIns="0" rIns="0" bIns="0" rtlCol="0" anchor="ctr"/>
+          <a:lstStyle/>
+          <a:p>
+            <a:pPr algn="r" indent="0" marL="0">
+              <a:buNone/>
+            </a:pPr>
+            <a:r>
+              <a:rPr lang="en-US" sz="1400" dirty="0">
+                <a:solidFill>
+                  <a:srgbClr val="FFFFFF"/>
+                </a:solidFill>
+                <a:latin typeface="Calibri" pitchFamily="34" charset="0"/>
+                <a:ea typeface="Calibri" pitchFamily="34" charset="-122"/>
+                <a:cs typeface="Calibri" pitchFamily="34" charset="-120"/>
+              </a:rPr>
+              <a:t>82%</a:t>
+            </a:r>
+            <a:endParaRPr lang="en-US" sz="1400" dirty="0"/>
+          </a:p>
+        </p:txBody>
+      </p:sp>
+      <p:sp>
+        <p:nvSpPr>
+          <p:cNvPr id="13" name="Text 11"/>
+          <p:cNvSpPr/>
+          <p:nvPr/>
+        </p:nvSpPr>
+        <p:spPr>
+          <a:xfrm>
+            <a:off x="9418320" y="2313432"/>
+            <a:ext cx="2011680" cy="347472"/>
+          </a:xfrm>
+          <a:prstGeom prst="rect">
+            <a:avLst/>
+          </a:prstGeom>
+          <a:noFill/>
+          <a:ln/>
+        </p:spPr>
+        <p:txBody>
+          <a:bodyPr wrap="square" lIns="0" tIns="0" rIns="0" bIns="0" rtlCol="0" anchor="ctr"/>
+          <a:lstStyle/>
+          <a:p>
+            <a:pPr algn="r" indent="0" marL="0">
+              <a:buNone/>
+            </a:pPr>
+            <a:r>
+              <a:rPr lang="en-US" sz="1600" b="1" dirty="0">
                 <a:solidFill>
                   <a:srgbClr val="2D8A72"/>
                 </a:solidFill>
@@ -4118,26 +4379,26 @@
                 <a:ea typeface="Cambria" pitchFamily="34" charset="-122"/>
                 <a:cs typeface="Cambria" pitchFamily="34" charset="-120"/>
               </a:rPr>
-              <a:t>+50 pts</a:t>
-            </a:r>
-            <a:endParaRPr lang="en-US" sz="4400" dirty="0"/>
-          </a:p>
-        </p:txBody>
-      </p:sp>
-      <p:sp>
-        <p:nvSpPr>
-          <p:cNvPr id="7" name="Shape 5"/>
-          <p:cNvSpPr/>
-          <p:nvPr/>
-        </p:nvSpPr>
-        <p:spPr>
-          <a:xfrm>
-            <a:off x="6172200" y="1828800"/>
-            <a:ext cx="5074920" cy="1920240"/>
+              <a:t>+42</a:t>
+            </a:r>
+            <a:endParaRPr lang="en-US" sz="1600" dirty="0"/>
+          </a:p>
+        </p:txBody>
+      </p:sp>
+      <p:sp>
+        <p:nvSpPr>
+          <p:cNvPr id="14" name="Shape 12"/>
+          <p:cNvSpPr/>
+          <p:nvPr/>
+        </p:nvSpPr>
+        <p:spPr>
+          <a:xfrm>
+            <a:off x="640080" y="2807208"/>
+            <a:ext cx="10908792" cy="548640"/>
           </a:xfrm>
           <a:prstGeom prst="roundRect">
             <a:avLst>
-              <a:gd name="adj" fmla="val 3810"/>
+              <a:gd name="adj" fmla="val 13333"/>
             </a:avLst>
           </a:prstGeom>
           <a:solidFill>
@@ -4153,180 +4414,784 @@
       </p:sp>
       <p:sp>
         <p:nvSpPr>
-          <p:cNvPr id="8" name="Text 6"/>
-          <p:cNvSpPr/>
-          <p:nvPr/>
-        </p:nvSpPr>
-        <p:spPr>
-          <a:xfrm>
-            <a:off x="6492240" y="2057400"/>
-            <a:ext cx="4434840" cy="365760"/>
-          </a:xfrm>
-          <a:prstGeom prst="rect">
-            <a:avLst/>
-          </a:prstGeom>
-          <a:noFill/>
-          <a:ln/>
-        </p:spPr>
-        <p:txBody>
-          <a:bodyPr wrap="square" lIns="0" tIns="0" rIns="0" bIns="0" rtlCol="0" anchor="ctr"/>
-          <a:lstStyle/>
-          <a:p>
-            <a:pPr indent="0" marL="0">
-              <a:buNone/>
-            </a:pPr>
-            <a:r>
-              <a:rPr lang="en-US" sz="1700" b="1" dirty="0">
+          <p:cNvPr id="15" name="Text 13"/>
+          <p:cNvSpPr/>
+          <p:nvPr/>
+        </p:nvSpPr>
+        <p:spPr>
+          <a:xfrm>
+            <a:off x="960120" y="2926080"/>
+            <a:ext cx="4754880" cy="320040"/>
+          </a:xfrm>
+          <a:prstGeom prst="rect">
+            <a:avLst/>
+          </a:prstGeom>
+          <a:noFill/>
+          <a:ln/>
+        </p:spPr>
+        <p:txBody>
+          <a:bodyPr wrap="square" lIns="0" tIns="0" rIns="0" bIns="0" rtlCol="0" anchor="ctr"/>
+          <a:lstStyle/>
+          <a:p>
+            <a:pPr indent="0" marL="0">
+              <a:buNone/>
+            </a:pPr>
+            <a:r>
+              <a:rPr lang="en-US" sz="1400" dirty="0">
                 <a:solidFill>
                   <a:srgbClr val="CBD5DD"/>
+                </a:solidFill>
+                <a:latin typeface="Consolas" pitchFamily="34" charset="0"/>
+                <a:ea typeface="Consolas" pitchFamily="34" charset="-122"/>
+                <a:cs typeface="Consolas" pitchFamily="34" charset="-120"/>
+              </a:rPr>
+              <a:t>warehouse-navigation</a:t>
+            </a:r>
+            <a:endParaRPr lang="en-US" sz="1400" dirty="0"/>
+          </a:p>
+        </p:txBody>
+      </p:sp>
+      <p:sp>
+        <p:nvSpPr>
+          <p:cNvPr id="16" name="Text 14"/>
+          <p:cNvSpPr/>
+          <p:nvPr/>
+        </p:nvSpPr>
+        <p:spPr>
+          <a:xfrm>
+            <a:off x="6126480" y="2926080"/>
+            <a:ext cx="1280160" cy="320040"/>
+          </a:xfrm>
+          <a:prstGeom prst="rect">
+            <a:avLst/>
+          </a:prstGeom>
+          <a:noFill/>
+          <a:ln/>
+        </p:spPr>
+        <p:txBody>
+          <a:bodyPr wrap="square" lIns="0" tIns="0" rIns="0" bIns="0" rtlCol="0" anchor="ctr"/>
+          <a:lstStyle/>
+          <a:p>
+            <a:pPr algn="r" indent="0" marL="0">
+              <a:buNone/>
+            </a:pPr>
+            <a:r>
+              <a:rPr lang="en-US" sz="1400" dirty="0">
+                <a:solidFill>
+                  <a:srgbClr val="8A99A8"/>
+                </a:solidFill>
+                <a:latin typeface="Calibri" pitchFamily="34" charset="0"/>
+                <a:ea typeface="Calibri" pitchFamily="34" charset="-122"/>
+                <a:cs typeface="Calibri" pitchFamily="34" charset="-120"/>
+              </a:rPr>
+              <a:t>61%</a:t>
+            </a:r>
+            <a:endParaRPr lang="en-US" sz="1400" dirty="0"/>
+          </a:p>
+        </p:txBody>
+      </p:sp>
+      <p:sp>
+        <p:nvSpPr>
+          <p:cNvPr id="17" name="Text 15"/>
+          <p:cNvSpPr/>
+          <p:nvPr/>
+        </p:nvSpPr>
+        <p:spPr>
+          <a:xfrm>
+            <a:off x="7680960" y="2926080"/>
+            <a:ext cx="1280160" cy="320040"/>
+          </a:xfrm>
+          <a:prstGeom prst="rect">
+            <a:avLst/>
+          </a:prstGeom>
+          <a:noFill/>
+          <a:ln/>
+        </p:spPr>
+        <p:txBody>
+          <a:bodyPr wrap="square" lIns="0" tIns="0" rIns="0" bIns="0" rtlCol="0" anchor="ctr"/>
+          <a:lstStyle/>
+          <a:p>
+            <a:pPr algn="r" indent="0" marL="0">
+              <a:buNone/>
+            </a:pPr>
+            <a:r>
+              <a:rPr lang="en-US" sz="1400" dirty="0">
+                <a:solidFill>
+                  <a:srgbClr val="FFFFFF"/>
+                </a:solidFill>
+                <a:latin typeface="Calibri" pitchFamily="34" charset="0"/>
+                <a:ea typeface="Calibri" pitchFamily="34" charset="-122"/>
+                <a:cs typeface="Calibri" pitchFamily="34" charset="-120"/>
+              </a:rPr>
+              <a:t>83%</a:t>
+            </a:r>
+            <a:endParaRPr lang="en-US" sz="1400" dirty="0"/>
+          </a:p>
+        </p:txBody>
+      </p:sp>
+      <p:sp>
+        <p:nvSpPr>
+          <p:cNvPr id="18" name="Text 16"/>
+          <p:cNvSpPr/>
+          <p:nvPr/>
+        </p:nvSpPr>
+        <p:spPr>
+          <a:xfrm>
+            <a:off x="9418320" y="2916936"/>
+            <a:ext cx="2011680" cy="347472"/>
+          </a:xfrm>
+          <a:prstGeom prst="rect">
+            <a:avLst/>
+          </a:prstGeom>
+          <a:noFill/>
+          <a:ln/>
+        </p:spPr>
+        <p:txBody>
+          <a:bodyPr wrap="square" lIns="0" tIns="0" rIns="0" bIns="0" rtlCol="0" anchor="ctr"/>
+          <a:lstStyle/>
+          <a:p>
+            <a:pPr algn="r" indent="0" marL="0">
+              <a:buNone/>
+            </a:pPr>
+            <a:r>
+              <a:rPr lang="en-US" sz="1600" b="1" dirty="0">
+                <a:solidFill>
+                  <a:srgbClr val="2D8A72"/>
                 </a:solidFill>
                 <a:latin typeface="Cambria" pitchFamily="34" charset="0"/>
                 <a:ea typeface="Cambria" pitchFamily="34" charset="-122"/>
                 <a:cs typeface="Cambria" pitchFamily="34" charset="-120"/>
               </a:rPr>
-              <a:t>Six skills loaded</a:t>
-            </a:r>
-            <a:endParaRPr lang="en-US" sz="1700" dirty="0"/>
-          </a:p>
-        </p:txBody>
-      </p:sp>
-      <p:sp>
-        <p:nvSpPr>
-          <p:cNvPr id="9" name="Text 7"/>
-          <p:cNvSpPr/>
-          <p:nvPr/>
-        </p:nvSpPr>
-        <p:spPr>
-          <a:xfrm>
-            <a:off x="6492240" y="2514600"/>
-            <a:ext cx="4434840" cy="822960"/>
-          </a:xfrm>
-          <a:prstGeom prst="rect">
-            <a:avLst/>
-          </a:prstGeom>
-          <a:noFill/>
-          <a:ln/>
-        </p:spPr>
-        <p:txBody>
-          <a:bodyPr wrap="square" lIns="0" tIns="0" rIns="0" bIns="0" rtlCol="0" anchor="ctr"/>
-          <a:lstStyle/>
-          <a:p>
-            <a:pPr indent="0" marL="0">
-              <a:buNone/>
-            </a:pPr>
-            <a:r>
-              <a:rPr lang="en-US" sz="4400" b="1" dirty="0">
-                <a:solidFill>
-                  <a:srgbClr val="E8663C"/>
+              <a:t>+23</a:t>
+            </a:r>
+            <a:endParaRPr lang="en-US" sz="1600" dirty="0"/>
+          </a:p>
+        </p:txBody>
+      </p:sp>
+      <p:sp>
+        <p:nvSpPr>
+          <p:cNvPr id="19" name="Shape 17"/>
+          <p:cNvSpPr/>
+          <p:nvPr/>
+        </p:nvSpPr>
+        <p:spPr>
+          <a:xfrm>
+            <a:off x="640080" y="3410712"/>
+            <a:ext cx="10908792" cy="548640"/>
+          </a:xfrm>
+          <a:prstGeom prst="roundRect">
+            <a:avLst>
+              <a:gd name="adj" fmla="val 13333"/>
+            </a:avLst>
+          </a:prstGeom>
+          <a:solidFill>
+            <a:srgbClr val="22303C"/>
+          </a:solidFill>
+          <a:ln w="12700">
+            <a:solidFill>
+              <a:srgbClr val="22303C"/>
+            </a:solidFill>
+            <a:prstDash val="solid"/>
+          </a:ln>
+        </p:spPr>
+      </p:sp>
+      <p:sp>
+        <p:nvSpPr>
+          <p:cNvPr id="20" name="Text 18"/>
+          <p:cNvSpPr/>
+          <p:nvPr/>
+        </p:nvSpPr>
+        <p:spPr>
+          <a:xfrm>
+            <a:off x="960120" y="3529584"/>
+            <a:ext cx="4754880" cy="320040"/>
+          </a:xfrm>
+          <a:prstGeom prst="rect">
+            <a:avLst/>
+          </a:prstGeom>
+          <a:noFill/>
+          <a:ln/>
+        </p:spPr>
+        <p:txBody>
+          <a:bodyPr wrap="square" lIns="0" tIns="0" rIns="0" bIns="0" rtlCol="0" anchor="ctr"/>
+          <a:lstStyle/>
+          <a:p>
+            <a:pPr indent="0" marL="0">
+              <a:buNone/>
+            </a:pPr>
+            <a:r>
+              <a:rPr lang="en-US" sz="1400" dirty="0">
+                <a:solidFill>
+                  <a:srgbClr val="CBD5DD"/>
+                </a:solidFill>
+                <a:latin typeface="Consolas" pitchFamily="34" charset="0"/>
+                <a:ea typeface="Consolas" pitchFamily="34" charset="-122"/>
+                <a:cs typeface="Consolas" pitchFamily="34" charset="-120"/>
+              </a:rPr>
+              <a:t>question-intake</a:t>
+            </a:r>
+            <a:endParaRPr lang="en-US" sz="1400" dirty="0"/>
+          </a:p>
+        </p:txBody>
+      </p:sp>
+      <p:sp>
+        <p:nvSpPr>
+          <p:cNvPr id="21" name="Text 19"/>
+          <p:cNvSpPr/>
+          <p:nvPr/>
+        </p:nvSpPr>
+        <p:spPr>
+          <a:xfrm>
+            <a:off x="6126480" y="3529584"/>
+            <a:ext cx="1280160" cy="320040"/>
+          </a:xfrm>
+          <a:prstGeom prst="rect">
+            <a:avLst/>
+          </a:prstGeom>
+          <a:noFill/>
+          <a:ln/>
+        </p:spPr>
+        <p:txBody>
+          <a:bodyPr wrap="square" lIns="0" tIns="0" rIns="0" bIns="0" rtlCol="0" anchor="ctr"/>
+          <a:lstStyle/>
+          <a:p>
+            <a:pPr algn="r" indent="0" marL="0">
+              <a:buNone/>
+            </a:pPr>
+            <a:r>
+              <a:rPr lang="en-US" sz="1400" dirty="0">
+                <a:solidFill>
+                  <a:srgbClr val="8A99A8"/>
+                </a:solidFill>
+                <a:latin typeface="Calibri" pitchFamily="34" charset="0"/>
+                <a:ea typeface="Calibri" pitchFamily="34" charset="-122"/>
+                <a:cs typeface="Calibri" pitchFamily="34" charset="-120"/>
+              </a:rPr>
+              <a:t>61%</a:t>
+            </a:r>
+            <a:endParaRPr lang="en-US" sz="1400" dirty="0"/>
+          </a:p>
+        </p:txBody>
+      </p:sp>
+      <p:sp>
+        <p:nvSpPr>
+          <p:cNvPr id="22" name="Text 20"/>
+          <p:cNvSpPr/>
+          <p:nvPr/>
+        </p:nvSpPr>
+        <p:spPr>
+          <a:xfrm>
+            <a:off x="7680960" y="3529584"/>
+            <a:ext cx="1280160" cy="320040"/>
+          </a:xfrm>
+          <a:prstGeom prst="rect">
+            <a:avLst/>
+          </a:prstGeom>
+          <a:noFill/>
+          <a:ln/>
+        </p:spPr>
+        <p:txBody>
+          <a:bodyPr wrap="square" lIns="0" tIns="0" rIns="0" bIns="0" rtlCol="0" anchor="ctr"/>
+          <a:lstStyle/>
+          <a:p>
+            <a:pPr algn="r" indent="0" marL="0">
+              <a:buNone/>
+            </a:pPr>
+            <a:r>
+              <a:rPr lang="en-US" sz="1400" dirty="0">
+                <a:solidFill>
+                  <a:srgbClr val="FFFFFF"/>
+                </a:solidFill>
+                <a:latin typeface="Calibri" pitchFamily="34" charset="0"/>
+                <a:ea typeface="Calibri" pitchFamily="34" charset="-122"/>
+                <a:cs typeface="Calibri" pitchFamily="34" charset="-120"/>
+              </a:rPr>
+              <a:t>82%</a:t>
+            </a:r>
+            <a:endParaRPr lang="en-US" sz="1400" dirty="0"/>
+          </a:p>
+        </p:txBody>
+      </p:sp>
+      <p:sp>
+        <p:nvSpPr>
+          <p:cNvPr id="23" name="Text 21"/>
+          <p:cNvSpPr/>
+          <p:nvPr/>
+        </p:nvSpPr>
+        <p:spPr>
+          <a:xfrm>
+            <a:off x="9418320" y="3520440"/>
+            <a:ext cx="2011680" cy="347472"/>
+          </a:xfrm>
+          <a:prstGeom prst="rect">
+            <a:avLst/>
+          </a:prstGeom>
+          <a:noFill/>
+          <a:ln/>
+        </p:spPr>
+        <p:txBody>
+          <a:bodyPr wrap="square" lIns="0" tIns="0" rIns="0" bIns="0" rtlCol="0" anchor="ctr"/>
+          <a:lstStyle/>
+          <a:p>
+            <a:pPr algn="r" indent="0" marL="0">
+              <a:buNone/>
+            </a:pPr>
+            <a:r>
+              <a:rPr lang="en-US" sz="1600" b="1" dirty="0">
+                <a:solidFill>
+                  <a:srgbClr val="2D8A72"/>
                 </a:solidFill>
                 <a:latin typeface="Cambria" pitchFamily="34" charset="0"/>
                 <a:ea typeface="Cambria" pitchFamily="34" charset="-122"/>
                 <a:cs typeface="Cambria" pitchFamily="34" charset="-120"/>
               </a:rPr>
-              <a:t>−9 pts</a:t>
-            </a:r>
-            <a:endParaRPr lang="en-US" sz="4400" dirty="0"/>
-          </a:p>
-        </p:txBody>
-      </p:sp>
-      <p:sp>
-        <p:nvSpPr>
-          <p:cNvPr id="10" name="Text 8"/>
-          <p:cNvSpPr/>
-          <p:nvPr/>
-        </p:nvSpPr>
-        <p:spPr>
-          <a:xfrm>
-            <a:off x="640080" y="3977640"/>
-            <a:ext cx="10908792" cy="411480"/>
-          </a:xfrm>
-          <a:prstGeom prst="rect">
-            <a:avLst/>
-          </a:prstGeom>
-          <a:noFill/>
-          <a:ln/>
-        </p:spPr>
-        <p:txBody>
-          <a:bodyPr wrap="square" lIns="0" tIns="0" rIns="0" bIns="0" rtlCol="0" anchor="ctr"/>
-          <a:lstStyle/>
-          <a:p>
-            <a:pPr indent="0" marL="0">
-              <a:buNone/>
-            </a:pPr>
-            <a:r>
-              <a:rPr lang="en-US" sz="2200" i="1" dirty="0">
+              <a:t>+21</a:t>
+            </a:r>
+            <a:endParaRPr lang="en-US" sz="1600" dirty="0"/>
+          </a:p>
+        </p:txBody>
+      </p:sp>
+      <p:sp>
+        <p:nvSpPr>
+          <p:cNvPr id="24" name="Shape 22"/>
+          <p:cNvSpPr/>
+          <p:nvPr/>
+        </p:nvSpPr>
+        <p:spPr>
+          <a:xfrm>
+            <a:off x="640080" y="4014216"/>
+            <a:ext cx="10908792" cy="548640"/>
+          </a:xfrm>
+          <a:prstGeom prst="roundRect">
+            <a:avLst>
+              <a:gd name="adj" fmla="val 13333"/>
+            </a:avLst>
+          </a:prstGeom>
+          <a:solidFill>
+            <a:srgbClr val="2E3E4C"/>
+          </a:solidFill>
+          <a:ln w="12700">
+            <a:solidFill>
+              <a:srgbClr val="2E3E4C"/>
+            </a:solidFill>
+            <a:prstDash val="solid"/>
+          </a:ln>
+        </p:spPr>
+      </p:sp>
+      <p:sp>
+        <p:nvSpPr>
+          <p:cNvPr id="25" name="Text 23"/>
+          <p:cNvSpPr/>
+          <p:nvPr/>
+        </p:nvSpPr>
+        <p:spPr>
+          <a:xfrm>
+            <a:off x="960120" y="4133088"/>
+            <a:ext cx="4754880" cy="320040"/>
+          </a:xfrm>
+          <a:prstGeom prst="rect">
+            <a:avLst/>
+          </a:prstGeom>
+          <a:noFill/>
+          <a:ln/>
+        </p:spPr>
+        <p:txBody>
+          <a:bodyPr wrap="square" lIns="0" tIns="0" rIns="0" bIns="0" rtlCol="0" anchor="ctr"/>
+          <a:lstStyle/>
+          <a:p>
+            <a:pPr indent="0" marL="0">
+              <a:buNone/>
+            </a:pPr>
+            <a:r>
+              <a:rPr lang="en-US" sz="1400" dirty="0">
+                <a:solidFill>
+                  <a:srgbClr val="CBD5DD"/>
+                </a:solidFill>
+                <a:latin typeface="Consolas" pitchFamily="34" charset="0"/>
+                <a:ea typeface="Consolas" pitchFamily="34" charset="-122"/>
+                <a:cs typeface="Consolas" pitchFamily="34" charset="-120"/>
+              </a:rPr>
+              <a:t>adversarial-sql-review</a:t>
+            </a:r>
+            <a:endParaRPr lang="en-US" sz="1400" dirty="0"/>
+          </a:p>
+        </p:txBody>
+      </p:sp>
+      <p:sp>
+        <p:nvSpPr>
+          <p:cNvPr id="26" name="Text 24"/>
+          <p:cNvSpPr/>
+          <p:nvPr/>
+        </p:nvSpPr>
+        <p:spPr>
+          <a:xfrm>
+            <a:off x="6126480" y="4133088"/>
+            <a:ext cx="1280160" cy="320040"/>
+          </a:xfrm>
+          <a:prstGeom prst="rect">
+            <a:avLst/>
+          </a:prstGeom>
+          <a:noFill/>
+          <a:ln/>
+        </p:spPr>
+        <p:txBody>
+          <a:bodyPr wrap="square" lIns="0" tIns="0" rIns="0" bIns="0" rtlCol="0" anchor="ctr"/>
+          <a:lstStyle/>
+          <a:p>
+            <a:pPr algn="r" indent="0" marL="0">
+              <a:buNone/>
+            </a:pPr>
+            <a:r>
+              <a:rPr lang="en-US" sz="1400" dirty="0">
+                <a:solidFill>
+                  <a:srgbClr val="8A99A8"/>
+                </a:solidFill>
+                <a:latin typeface="Calibri" pitchFamily="34" charset="0"/>
+                <a:ea typeface="Calibri" pitchFamily="34" charset="-122"/>
+                <a:cs typeface="Calibri" pitchFamily="34" charset="-120"/>
+              </a:rPr>
+              <a:t>54%</a:t>
+            </a:r>
+            <a:endParaRPr lang="en-US" sz="1400" dirty="0"/>
+          </a:p>
+        </p:txBody>
+      </p:sp>
+      <p:sp>
+        <p:nvSpPr>
+          <p:cNvPr id="27" name="Text 25"/>
+          <p:cNvSpPr/>
+          <p:nvPr/>
+        </p:nvSpPr>
+        <p:spPr>
+          <a:xfrm>
+            <a:off x="7680960" y="4133088"/>
+            <a:ext cx="1280160" cy="320040"/>
+          </a:xfrm>
+          <a:prstGeom prst="rect">
+            <a:avLst/>
+          </a:prstGeom>
+          <a:noFill/>
+          <a:ln/>
+        </p:spPr>
+        <p:txBody>
+          <a:bodyPr wrap="square" lIns="0" tIns="0" rIns="0" bIns="0" rtlCol="0" anchor="ctr"/>
+          <a:lstStyle/>
+          <a:p>
+            <a:pPr algn="r" indent="0" marL="0">
+              <a:buNone/>
+            </a:pPr>
+            <a:r>
+              <a:rPr lang="en-US" sz="1400" dirty="0">
                 <a:solidFill>
                   <a:srgbClr val="FFFFFF"/>
+                </a:solidFill>
+                <a:latin typeface="Calibri" pitchFamily="34" charset="0"/>
+                <a:ea typeface="Calibri" pitchFamily="34" charset="-122"/>
+                <a:cs typeface="Calibri" pitchFamily="34" charset="-120"/>
+              </a:rPr>
+              <a:t>72%</a:t>
+            </a:r>
+            <a:endParaRPr lang="en-US" sz="1400" dirty="0"/>
+          </a:p>
+        </p:txBody>
+      </p:sp>
+      <p:sp>
+        <p:nvSpPr>
+          <p:cNvPr id="28" name="Text 26"/>
+          <p:cNvSpPr/>
+          <p:nvPr/>
+        </p:nvSpPr>
+        <p:spPr>
+          <a:xfrm>
+            <a:off x="9418320" y="4123944"/>
+            <a:ext cx="2011680" cy="347472"/>
+          </a:xfrm>
+          <a:prstGeom prst="rect">
+            <a:avLst/>
+          </a:prstGeom>
+          <a:noFill/>
+          <a:ln/>
+        </p:spPr>
+        <p:txBody>
+          <a:bodyPr wrap="square" lIns="0" tIns="0" rIns="0" bIns="0" rtlCol="0" anchor="ctr"/>
+          <a:lstStyle/>
+          <a:p>
+            <a:pPr algn="r" indent="0" marL="0">
+              <a:buNone/>
+            </a:pPr>
+            <a:r>
+              <a:rPr lang="en-US" sz="1600" b="1" dirty="0">
+                <a:solidFill>
+                  <a:srgbClr val="2D8A72"/>
                 </a:solidFill>
                 <a:latin typeface="Cambria" pitchFamily="34" charset="0"/>
                 <a:ea typeface="Cambria" pitchFamily="34" charset="-122"/>
                 <a:cs typeface="Cambria" pitchFamily="34" charset="-120"/>
               </a:rPr>
-              <a:t>Same skills. Same model. Same warehouse. Opposite conclusions.</a:t>
-            </a:r>
-            <a:endParaRPr lang="en-US" sz="2200" dirty="0"/>
-          </a:p>
-        </p:txBody>
-      </p:sp>
-      <p:sp>
-        <p:nvSpPr>
-          <p:cNvPr id="11" name="Text 9"/>
+              <a:t>+18</a:t>
+            </a:r>
+            <a:endParaRPr lang="en-US" sz="1600" dirty="0"/>
+          </a:p>
+        </p:txBody>
+      </p:sp>
+      <p:sp>
+        <p:nvSpPr>
+          <p:cNvPr id="29" name="Shape 27"/>
           <p:cNvSpPr/>
           <p:nvPr/>
         </p:nvSpPr>
         <p:spPr>
           <a:xfrm>
             <a:off x="640080" y="4617720"/>
-            <a:ext cx="10908792" cy="822960"/>
-          </a:xfrm>
-          <a:prstGeom prst="rect">
-            <a:avLst/>
-          </a:prstGeom>
-          <a:noFill/>
-          <a:ln/>
-        </p:spPr>
-        <p:txBody>
-          <a:bodyPr wrap="square" lIns="0" tIns="0" rIns="0" bIns="0" rtlCol="0" anchor="ctr"/>
-          <a:lstStyle/>
-          <a:p>
-            <a:pPr indent="0" marL="0">
-              <a:lnSpc>
-                <a:spcPts val="2400"/>
-              </a:lnSpc>
-              <a:buNone/>
-            </a:pPr>
-            <a:r>
-              <a:rPr lang="en-US" sz="1500" b="1" dirty="0">
-                <a:solidFill>
-                  <a:srgbClr val="FFFFFF"/>
+            <a:ext cx="10908792" cy="548640"/>
+          </a:xfrm>
+          <a:prstGeom prst="roundRect">
+            <a:avLst>
+              <a:gd name="adj" fmla="val 13333"/>
+            </a:avLst>
+          </a:prstGeom>
+          <a:solidFill>
+            <a:srgbClr val="22303C"/>
+          </a:solidFill>
+          <a:ln w="12700">
+            <a:solidFill>
+              <a:srgbClr val="22303C"/>
+            </a:solidFill>
+            <a:prstDash val="solid"/>
+          </a:ln>
+        </p:spPr>
+      </p:sp>
+      <p:sp>
+        <p:nvSpPr>
+          <p:cNvPr id="30" name="Text 28"/>
+          <p:cNvSpPr/>
+          <p:nvPr/>
+        </p:nvSpPr>
+        <p:spPr>
+          <a:xfrm>
+            <a:off x="960120" y="4736592"/>
+            <a:ext cx="4754880" cy="320040"/>
+          </a:xfrm>
+          <a:prstGeom prst="rect">
+            <a:avLst/>
+          </a:prstGeom>
+          <a:noFill/>
+          <a:ln/>
+        </p:spPr>
+        <p:txBody>
+          <a:bodyPr wrap="square" lIns="0" tIns="0" rIns="0" bIns="0" rtlCol="0" anchor="ctr"/>
+          <a:lstStyle/>
+          <a:p>
+            <a:pPr indent="0" marL="0">
+              <a:buNone/>
+            </a:pPr>
+            <a:r>
+              <a:rPr lang="en-US" sz="1400" dirty="0">
+                <a:solidFill>
+                  <a:srgbClr val="CBD5DD"/>
+                </a:solidFill>
+                <a:latin typeface="Consolas" pitchFamily="34" charset="0"/>
+                <a:ea typeface="Consolas" pitchFamily="34" charset="-122"/>
+                <a:cs typeface="Consolas" pitchFamily="34" charset="-120"/>
+              </a:rPr>
+              <a:t>causal-claim-guardrail</a:t>
+            </a:r>
+            <a:endParaRPr lang="en-US" sz="1400" dirty="0"/>
+          </a:p>
+        </p:txBody>
+      </p:sp>
+      <p:sp>
+        <p:nvSpPr>
+          <p:cNvPr id="31" name="Text 29"/>
+          <p:cNvSpPr/>
+          <p:nvPr/>
+        </p:nvSpPr>
+        <p:spPr>
+          <a:xfrm>
+            <a:off x="6126480" y="4736592"/>
+            <a:ext cx="1280160" cy="320040"/>
+          </a:xfrm>
+          <a:prstGeom prst="rect">
+            <a:avLst/>
+          </a:prstGeom>
+          <a:noFill/>
+          <a:ln/>
+        </p:spPr>
+        <p:txBody>
+          <a:bodyPr wrap="square" lIns="0" tIns="0" rIns="0" bIns="0" rtlCol="0" anchor="ctr"/>
+          <a:lstStyle/>
+          <a:p>
+            <a:pPr algn="r" indent="0" marL="0">
+              <a:buNone/>
+            </a:pPr>
+            <a:r>
+              <a:rPr lang="en-US" sz="1400" dirty="0">
+                <a:solidFill>
+                  <a:srgbClr val="8A99A8"/>
                 </a:solidFill>
                 <a:latin typeface="Calibri" pitchFamily="34" charset="0"/>
                 <a:ea typeface="Calibri" pitchFamily="34" charset="-122"/>
                 <a:cs typeface="Calibri" pitchFamily="34" charset="-120"/>
               </a:rPr>
-              <a:t>Negative tests degraded 93% → 73%.</a:t>
-            </a:r>
-            <a:endParaRPr lang="en-US" sz="1500" dirty="0"/>
-          </a:p>
-          <a:p>
-            <a:pPr indent="0" marL="0">
-              <a:lnSpc>
-                <a:spcPts val="2400"/>
-              </a:lnSpc>
-              <a:buNone/>
-            </a:pPr>
-            <a:r>
-              <a:rPr lang="en-US" sz="1500" dirty="0">
-                <a:solidFill>
-                  <a:srgbClr val="CBD5DD"/>
+              <a:t>74%</a:t>
+            </a:r>
+            <a:endParaRPr lang="en-US" sz="1400" dirty="0"/>
+          </a:p>
+        </p:txBody>
+      </p:sp>
+      <p:sp>
+        <p:nvSpPr>
+          <p:cNvPr id="32" name="Text 30"/>
+          <p:cNvSpPr/>
+          <p:nvPr/>
+        </p:nvSpPr>
+        <p:spPr>
+          <a:xfrm>
+            <a:off x="7680960" y="4736592"/>
+            <a:ext cx="1280160" cy="320040"/>
+          </a:xfrm>
+          <a:prstGeom prst="rect">
+            <a:avLst/>
+          </a:prstGeom>
+          <a:noFill/>
+          <a:ln/>
+        </p:spPr>
+        <p:txBody>
+          <a:bodyPr wrap="square" lIns="0" tIns="0" rIns="0" bIns="0" rtlCol="0" anchor="ctr"/>
+          <a:lstStyle/>
+          <a:p>
+            <a:pPr algn="r" indent="0" marL="0">
+              <a:buNone/>
+            </a:pPr>
+            <a:r>
+              <a:rPr lang="en-US" sz="1400" dirty="0">
+                <a:solidFill>
+                  <a:srgbClr val="FFFFFF"/>
                 </a:solidFill>
                 <a:latin typeface="Calibri" pitchFamily="34" charset="0"/>
                 <a:ea typeface="Calibri" pitchFamily="34" charset="-122"/>
                 <a:cs typeface="Calibri" pitchFamily="34" charset="-120"/>
               </a:rPr>
-              <a:t>12 of 28 evals flipped by 60+ points, in both directions. Only 11 held steady.</a:t>
+              <a:t>87%</a:t>
+            </a:r>
+            <a:endParaRPr lang="en-US" sz="1400" dirty="0"/>
+          </a:p>
+        </p:txBody>
+      </p:sp>
+      <p:sp>
+        <p:nvSpPr>
+          <p:cNvPr id="33" name="Text 31"/>
+          <p:cNvSpPr/>
+          <p:nvPr/>
+        </p:nvSpPr>
+        <p:spPr>
+          <a:xfrm>
+            <a:off x="9418320" y="4727448"/>
+            <a:ext cx="2011680" cy="347472"/>
+          </a:xfrm>
+          <a:prstGeom prst="rect">
+            <a:avLst/>
+          </a:prstGeom>
+          <a:noFill/>
+          <a:ln/>
+        </p:spPr>
+        <p:txBody>
+          <a:bodyPr wrap="square" lIns="0" tIns="0" rIns="0" bIns="0" rtlCol="0" anchor="ctr"/>
+          <a:lstStyle/>
+          <a:p>
+            <a:pPr algn="r" indent="0" marL="0">
+              <a:buNone/>
+            </a:pPr>
+            <a:r>
+              <a:rPr lang="en-US" sz="1600" b="1" dirty="0">
+                <a:solidFill>
+                  <a:srgbClr val="2D8A72"/>
+                </a:solidFill>
+                <a:latin typeface="Cambria" pitchFamily="34" charset="0"/>
+                <a:ea typeface="Cambria" pitchFamily="34" charset="-122"/>
+                <a:cs typeface="Cambria" pitchFamily="34" charset="-120"/>
+              </a:rPr>
+              <a:t>+13</a:t>
+            </a:r>
+            <a:endParaRPr lang="en-US" sz="1600" dirty="0"/>
+          </a:p>
+        </p:txBody>
+      </p:sp>
+      <p:sp>
+        <p:nvSpPr>
+          <p:cNvPr id="34" name="Text 32"/>
+          <p:cNvSpPr/>
+          <p:nvPr/>
+        </p:nvSpPr>
+        <p:spPr>
+          <a:xfrm>
+            <a:off x="640080" y="5349240"/>
+            <a:ext cx="10908792" cy="365760"/>
+          </a:xfrm>
+          <a:prstGeom prst="rect">
+            <a:avLst/>
+          </a:prstGeom>
+          <a:noFill/>
+          <a:ln/>
+        </p:spPr>
+        <p:txBody>
+          <a:bodyPr wrap="square" lIns="0" tIns="0" rIns="0" bIns="0" rtlCol="0" anchor="ctr"/>
+          <a:lstStyle/>
+          <a:p>
+            <a:pPr indent="0" marL="0">
+              <a:buNone/>
+            </a:pPr>
+            <a:r>
+              <a:rPr lang="en-US" sz="1500" dirty="0">
+                <a:solidFill>
+                  <a:srgbClr val="CBD5DD"/>
+                </a:solidFill>
+                <a:latin typeface="Calibri" pitchFamily="34" charset="0"/>
+                <a:ea typeface="Calibri" pitchFamily="34" charset="-122"/>
+                <a:cs typeface="Calibri" pitchFamily="34" charset="-120"/>
+              </a:rPr>
+              <a:t>29 paired observations · mean +28 pts · 95% CI +12 to +44 · p = 0.009</a:t>
             </a:r>
             <a:endParaRPr lang="en-US" sz="1500" dirty="0"/>
+          </a:p>
+        </p:txBody>
+      </p:sp>
+      <p:sp>
+        <p:nvSpPr>
+          <p:cNvPr id="35" name="Text 33"/>
+          <p:cNvSpPr/>
+          <p:nvPr/>
+        </p:nvSpPr>
+        <p:spPr>
+          <a:xfrm>
+            <a:off x="640080" y="5715000"/>
+            <a:ext cx="10908792" cy="365760"/>
+          </a:xfrm>
+          <a:prstGeom prst="rect">
+            <a:avLst/>
+          </a:prstGeom>
+          <a:noFill/>
+          <a:ln/>
+        </p:spPr>
+        <p:txBody>
+          <a:bodyPr wrap="square" lIns="0" tIns="0" rIns="0" bIns="0" rtlCol="0" anchor="ctr"/>
+          <a:lstStyle/>
+          <a:p>
+            <a:pPr indent="0" marL="0">
+              <a:buNone/>
+            </a:pPr>
+            <a:r>
+              <a:rPr lang="en-US" sz="1300" i="1" dirty="0">
+                <a:solidFill>
+                  <a:srgbClr val="8A99A8"/>
+                </a:solidFill>
+                <a:latin typeface="Calibri" pitchFamily="34" charset="0"/>
+                <a:ea typeface="Calibri" pitchFamily="34" charset="-122"/>
+                <a:cs typeface="Calibri" pitchFamily="34" charset="-120"/>
+              </a:rPr>
+              <a:t>Single model, single session, synthetic warehouse, authors' own evals.</a:t>
+            </a:r>
+            <a:endParaRPr lang="en-US" sz="1300" dirty="0"/>
           </a:p>
         </p:txBody>
       </p:sp>
@@ -4395,7 +5260,7 @@
                 <a:ea typeface="Calibri" pitchFamily="34" charset="-122"/>
                 <a:cs typeface="Calibri" pitchFamily="34" charset="-120"/>
               </a:rPr>
-              <a:t>THE DIAGNOSIS</a:t>
+              <a:t>WHAT THE HEADLINE HIDES</a:t>
             </a:r>
             <a:endParaRPr lang="en-US" sz="1100" dirty="0"/>
           </a:p>
@@ -4434,7 +5299,7 @@
                 <a:ea typeface="Cambria" pitchFamily="34" charset="-122"/>
                 <a:cs typeface="Cambria" pitchFamily="34" charset="-120"/>
               </a:rPr>
-              <a:t>How you load skills matters more than what's in them</a:t>
+              <a:t>Three things that belong with that number</a:t>
             </a:r>
             <a:endParaRPr lang="en-US" sz="3400" dirty="0"/>
           </a:p>
@@ -4448,12 +5313,12 @@
         </p:nvSpPr>
         <p:spPr>
           <a:xfrm>
-            <a:off x="640080" y="1691640"/>
-            <a:ext cx="10908792" cy="1371600"/>
+            <a:off x="640080" y="1645920"/>
+            <a:ext cx="10908792" cy="1234440"/>
           </a:xfrm>
           <a:prstGeom prst="roundRect">
             <a:avLst>
-              <a:gd name="adj" fmla="val 5333"/>
+              <a:gd name="adj" fmla="val 5926"/>
             </a:avLst>
           </a:prstGeom>
           <a:solidFill>
@@ -4475,24 +5340,24 @@
         </p:nvSpPr>
         <p:spPr>
           <a:xfrm>
-            <a:off x="1005840" y="1920240"/>
-            <a:ext cx="10177272" cy="411480"/>
-          </a:xfrm>
-          <a:prstGeom prst="rect">
-            <a:avLst/>
-          </a:prstGeom>
-          <a:noFill/>
-          <a:ln/>
-        </p:spPr>
-        <p:txBody>
-          <a:bodyPr wrap="square" lIns="0" tIns="0" rIns="0" bIns="0" rtlCol="0" anchor="ctr"/>
-          <a:lstStyle/>
-          <a:p>
-            <a:pPr indent="0" marL="0">
-              <a:buNone/>
-            </a:pPr>
-            <a:r>
-              <a:rPr lang="en-US" sz="2400" b="1" dirty="0">
+            <a:off x="1005840" y="1847088"/>
+            <a:ext cx="10177272" cy="384048"/>
+          </a:xfrm>
+          <a:prstGeom prst="rect">
+            <a:avLst/>
+          </a:prstGeom>
+          <a:noFill/>
+          <a:ln/>
+        </p:spPr>
+        <p:txBody>
+          <a:bodyPr wrap="square" lIns="0" tIns="0" rIns="0" bIns="0" rtlCol="0" anchor="ctr"/>
+          <a:lstStyle/>
+          <a:p>
+            <a:pPr indent="0" marL="0">
+              <a:buNone/>
+            </a:pPr>
+            <a:r>
+              <a:rPr lang="en-US" sz="2200" b="1" dirty="0">
                 <a:solidFill>
                   <a:srgbClr val="E8663C"/>
                 </a:solidFill>
@@ -4500,9 +5365,9 @@
                 <a:ea typeface="Cambria" pitchFamily="34" charset="-122"/>
                 <a:cs typeface="Cambria" pitchFamily="34" charset="-120"/>
               </a:rPr>
-              <a:t>11,253 tokens of instructions attached to a 17-token question.</a:t>
-            </a:r>
-            <a:endParaRPr lang="en-US" sz="2400" dirty="0"/>
+              <a:t>Skills over-fire. Negative tests fell 87% to 70%.</a:t>
+            </a:r>
+            <a:endParaRPr lang="en-US" sz="2200" dirty="0"/>
           </a:p>
         </p:txBody>
       </p:sp>
@@ -4514,8 +5379,8 @@
         </p:nvSpPr>
         <p:spPr>
           <a:xfrm>
-            <a:off x="1005840" y="2377440"/>
-            <a:ext cx="10177272" cy="457200"/>
+            <a:off x="1005840" y="2286000"/>
+            <a:ext cx="10177272" cy="411480"/>
           </a:xfrm>
           <a:prstGeom prst="rect">
             <a:avLst/>
@@ -4539,7 +5404,7 @@
                 <a:ea typeface="Calibri" pitchFamily="34" charset="-122"/>
                 <a:cs typeface="Calibri" pitchFamily="34" charset="-120"/>
               </a:rPr>
-              <a:t>Every skill file injected into every question — roughly 600x the size of the ask.</a:t>
+              <a:t>The worst case attaches a full provenance footer to a schema lookup. A real cost, not noise.</a:t>
             </a:r>
             <a:endParaRPr lang="en-US" sz="1500" dirty="0"/>
           </a:p>
@@ -4553,12 +5418,12 @@
         </p:nvSpPr>
         <p:spPr>
           <a:xfrm>
-            <a:off x="640080" y="3291840"/>
-            <a:ext cx="3520440" cy="2148840"/>
+            <a:off x="640080" y="3017520"/>
+            <a:ext cx="10908792" cy="1234440"/>
           </a:xfrm>
           <a:prstGeom prst="roundRect">
             <a:avLst>
-              <a:gd name="adj" fmla="val 3404"/>
+              <a:gd name="adj" fmla="val 5926"/>
             </a:avLst>
           </a:prstGeom>
           <a:solidFill>
@@ -4580,24 +5445,24 @@
         </p:nvSpPr>
         <p:spPr>
           <a:xfrm>
-            <a:off x="914400" y="3520440"/>
-            <a:ext cx="2971800" cy="365760"/>
-          </a:xfrm>
-          <a:prstGeom prst="rect">
-            <a:avLst/>
-          </a:prstGeom>
-          <a:noFill/>
-          <a:ln/>
-        </p:spPr>
-        <p:txBody>
-          <a:bodyPr wrap="square" lIns="0" tIns="0" rIns="0" bIns="0" rtlCol="0" anchor="ctr"/>
-          <a:lstStyle/>
-          <a:p>
-            <a:pPr indent="0" marL="0">
-              <a:buNone/>
-            </a:pPr>
-            <a:r>
-              <a:rPr lang="en-US" sz="1600" b="1" dirty="0">
+            <a:off x="1005840" y="3218688"/>
+            <a:ext cx="10177272" cy="384048"/>
+          </a:xfrm>
+          <a:prstGeom prst="rect">
+            <a:avLst/>
+          </a:prstGeom>
+          <a:noFill/>
+          <a:ln/>
+        </p:spPr>
+        <p:txBody>
+          <a:bodyPr wrap="square" lIns="0" tIns="0" rIns="0" bIns="0" rtlCol="0" anchor="ctr"/>
+          <a:lstStyle/>
+          <a:p>
+            <a:pPr indent="0" marL="0">
+              <a:buNone/>
+            </a:pPr>
+            <a:r>
+              <a:rPr lang="en-US" sz="2200" b="1" dirty="0">
                 <a:solidFill>
                   <a:srgbClr val="22303C"/>
                 </a:solidFill>
@@ -4605,9 +5470,9 @@
                 <a:ea typeface="Cambria" pitchFamily="34" charset="-122"/>
                 <a:cs typeface="Cambria" pitchFamily="34" charset="-120"/>
               </a:rPr>
-              <a:t>What we measured</a:t>
-            </a:r>
-            <a:endParaRPr lang="en-US" sz="1600" dirty="0"/>
+              <a:t>Five runs died on the turn budget — and not at random.</a:t>
+            </a:r>
+            <a:endParaRPr lang="en-US" sz="2200" dirty="0"/>
           </a:p>
         </p:txBody>
       </p:sp>
@@ -4619,24 +5484,24 @@
         </p:nvSpPr>
         <p:spPr>
           <a:xfrm>
-            <a:off x="914400" y="3931920"/>
-            <a:ext cx="2971800" cy="1371600"/>
-          </a:xfrm>
-          <a:prstGeom prst="rect">
-            <a:avLst/>
-          </a:prstGeom>
-          <a:noFill/>
-          <a:ln/>
-        </p:spPr>
-        <p:txBody>
-          <a:bodyPr wrap="square" lIns="0" tIns="0" rIns="0" bIns="0" rtlCol="0" anchor="ctr"/>
-          <a:lstStyle/>
-          <a:p>
-            <a:pPr indent="0" marL="0">
-              <a:buNone/>
-            </a:pPr>
-            <a:r>
-              <a:rPr lang="en-US" sz="1300" dirty="0">
+            <a:off x="1005840" y="3657600"/>
+            <a:ext cx="10177272" cy="411480"/>
+          </a:xfrm>
+          <a:prstGeom prst="rect">
+            <a:avLst/>
+          </a:prstGeom>
+          <a:noFill/>
+          <a:ln/>
+        </p:spPr>
+        <p:txBody>
+          <a:bodyPr wrap="square" lIns="0" tIns="0" rIns="0" bIns="0" rtlCol="0" anchor="ctr"/>
+          <a:lstStyle/>
+          <a:p>
+            <a:pPr indent="0" marL="0">
+              <a:buNone/>
+            </a:pPr>
+            <a:r>
+              <a:rPr lang="en-US" sz="1500" dirty="0">
                 <a:solidFill>
                   <a:srgbClr val="5A6B7A"/>
                 </a:solidFill>
@@ -4644,9 +5509,9 @@
                 <a:ea typeface="Calibri" pitchFamily="34" charset="-122"/>
                 <a:cs typeface="Calibri" pitchFamily="34" charset="-120"/>
               </a:rPr>
-              <a:t>Context dilution. The agent trying to satisfy six sets of instructions at once — hedging clean queries, interrogating specified questions.</a:t>
-            </a:r>
-            <a:endParaRPr lang="en-US" sz="1300" dirty="0"/>
+              <a:t>Four of the five were in the slice reporting the largest gain. Losing the hardest runs biases the estimate upward.</a:t>
+            </a:r>
+            <a:endParaRPr lang="en-US" sz="1500" dirty="0"/>
           </a:p>
         </p:txBody>
       </p:sp>
@@ -4658,20 +5523,20 @@
         </p:nvSpPr>
         <p:spPr>
           <a:xfrm>
-            <a:off x="4544568" y="3291840"/>
-            <a:ext cx="3520440" cy="2148840"/>
+            <a:off x="640080" y="4389120"/>
+            <a:ext cx="10908792" cy="1371600"/>
           </a:xfrm>
           <a:prstGeom prst="roundRect">
             <a:avLst>
-              <a:gd name="adj" fmla="val 3404"/>
+              <a:gd name="adj" fmla="val 5333"/>
             </a:avLst>
           </a:prstGeom>
           <a:solidFill>
-            <a:srgbClr val="F2F4F6"/>
+            <a:srgbClr val="E6F2EE"/>
           </a:solidFill>
           <a:ln w="12700">
             <a:solidFill>
-              <a:srgbClr val="F2F4F6"/>
+              <a:srgbClr val="E6F2EE"/>
             </a:solidFill>
             <a:prstDash val="solid"/>
           </a:ln>
@@ -4685,34 +5550,34 @@
         </p:nvSpPr>
         <p:spPr>
           <a:xfrm>
-            <a:off x="4818888" y="3520440"/>
-            <a:ext cx="2971800" cy="365760"/>
-          </a:xfrm>
-          <a:prstGeom prst="rect">
-            <a:avLst/>
-          </a:prstGeom>
-          <a:noFill/>
-          <a:ln/>
-        </p:spPr>
-        <p:txBody>
-          <a:bodyPr wrap="square" lIns="0" tIns="0" rIns="0" bIns="0" rtlCol="0" anchor="ctr"/>
-          <a:lstStyle/>
-          <a:p>
-            <a:pPr indent="0" marL="0">
-              <a:buNone/>
-            </a:pPr>
-            <a:r>
-              <a:rPr lang="en-US" sz="1600" b="1" dirty="0">
-                <a:solidFill>
-                  <a:srgbClr val="22303C"/>
+            <a:off x="1005840" y="4590288"/>
+            <a:ext cx="10177272" cy="384048"/>
+          </a:xfrm>
+          <a:prstGeom prst="rect">
+            <a:avLst/>
+          </a:prstGeom>
+          <a:noFill/>
+          <a:ln/>
+        </p:spPr>
+        <p:txBody>
+          <a:bodyPr wrap="square" lIns="0" tIns="0" rIns="0" bIns="0" rtlCol="0" anchor="ctr"/>
+          <a:lstStyle/>
+          <a:p>
+            <a:pPr indent="0" marL="0">
+              <a:buNone/>
+            </a:pPr>
+            <a:r>
+              <a:rPr lang="en-US" sz="2200" b="1" dirty="0">
+                <a:solidFill>
+                  <a:srgbClr val="2D8A72"/>
                 </a:solidFill>
                 <a:latin typeface="Cambria" pitchFamily="34" charset="0"/>
                 <a:ea typeface="Cambria" pitchFamily="34" charset="-122"/>
                 <a:cs typeface="Cambria" pitchFamily="34" charset="-120"/>
               </a:rPr>
-              <a:t>What we meant to measure</a:t>
-            </a:r>
-            <a:endParaRPr lang="en-US" sz="1600" dirty="0"/>
+              <a:t>It survives the sensitivity analysis anyway.</a:t>
+            </a:r>
+            <a:endParaRPr lang="en-US" sz="2200" dirty="0"/>
           </a:p>
         </p:txBody>
       </p:sp>
@@ -4724,139 +5589,34 @@
         </p:nvSpPr>
         <p:spPr>
           <a:xfrm>
-            <a:off x="4818888" y="3931920"/>
-            <a:ext cx="2971800" cy="1371600"/>
-          </a:xfrm>
-          <a:prstGeom prst="rect">
-            <a:avLst/>
-          </a:prstGeom>
-          <a:noFill/>
-          <a:ln/>
-        </p:spPr>
-        <p:txBody>
-          <a:bodyPr wrap="square" lIns="0" tIns="0" rIns="0" bIns="0" rtlCol="0" anchor="ctr"/>
-          <a:lstStyle/>
-          <a:p>
-            <a:pPr indent="0" marL="0">
-              <a:buNone/>
-            </a:pPr>
-            <a:r>
-              <a:rPr lang="en-US" sz="1300" dirty="0">
-                <a:solidFill>
-                  <a:srgbClr val="5A6B7A"/>
+            <a:off x="1005840" y="5029200"/>
+            <a:ext cx="10177272" cy="594360"/>
+          </a:xfrm>
+          <a:prstGeom prst="rect">
+            <a:avLst/>
+          </a:prstGeom>
+          <a:noFill/>
+          <a:ln/>
+        </p:spPr>
+        <p:txBody>
+          <a:bodyPr wrap="square" lIns="0" tIns="0" rIns="0" bIns="0" rtlCol="0" anchor="ctr"/>
+          <a:lstStyle/>
+          <a:p>
+            <a:pPr indent="0" marL="0">
+              <a:buNone/>
+            </a:pPr>
+            <a:r>
+              <a:rPr lang="en-US" sz="1500" dirty="0">
+                <a:solidFill>
+                  <a:srgbClr val="1F5F4C"/>
                 </a:solidFill>
                 <a:latin typeface="Calibri" pitchFamily="34" charset="0"/>
                 <a:ea typeface="Calibri" pitchFamily="34" charset="-122"/>
                 <a:cs typeface="Calibri" pitchFamily="34" charset="-120"/>
               </a:rPr>
-              <a:t>Skill quality. Whether the right instructions, delivered to the right question, improve the answer.</a:t>
-            </a:r>
-            <a:endParaRPr lang="en-US" sz="1300" dirty="0"/>
-          </a:p>
-        </p:txBody>
-      </p:sp>
-      <p:sp>
-        <p:nvSpPr>
-          <p:cNvPr id="13" name="Shape 11"/>
-          <p:cNvSpPr/>
-          <p:nvPr/>
-        </p:nvSpPr>
-        <p:spPr>
-          <a:xfrm>
-            <a:off x="8449056" y="3291840"/>
-            <a:ext cx="3520440" cy="2148840"/>
-          </a:xfrm>
-          <a:prstGeom prst="roundRect">
-            <a:avLst>
-              <a:gd name="adj" fmla="val 3404"/>
-            </a:avLst>
-          </a:prstGeom>
-          <a:solidFill>
-            <a:srgbClr val="F2F4F6"/>
-          </a:solidFill>
-          <a:ln w="12700">
-            <a:solidFill>
-              <a:srgbClr val="F2F4F6"/>
-            </a:solidFill>
-            <a:prstDash val="solid"/>
-          </a:ln>
-        </p:spPr>
-      </p:sp>
-      <p:sp>
-        <p:nvSpPr>
-          <p:cNvPr id="14" name="Text 12"/>
-          <p:cNvSpPr/>
-          <p:nvPr/>
-        </p:nvSpPr>
-        <p:spPr>
-          <a:xfrm>
-            <a:off x="8723376" y="3520440"/>
-            <a:ext cx="2971800" cy="365760"/>
-          </a:xfrm>
-          <a:prstGeom prst="rect">
-            <a:avLst/>
-          </a:prstGeom>
-          <a:noFill/>
-          <a:ln/>
-        </p:spPr>
-        <p:txBody>
-          <a:bodyPr wrap="square" lIns="0" tIns="0" rIns="0" bIns="0" rtlCol="0" anchor="ctr"/>
-          <a:lstStyle/>
-          <a:p>
-            <a:pPr indent="0" marL="0">
-              <a:buNone/>
-            </a:pPr>
-            <a:r>
-              <a:rPr lang="en-US" sz="1600" b="1" dirty="0">
-                <a:solidFill>
-                  <a:srgbClr val="22303C"/>
-                </a:solidFill>
-                <a:latin typeface="Cambria" pitchFamily="34" charset="0"/>
-                <a:ea typeface="Cambria" pitchFamily="34" charset="-122"/>
-                <a:cs typeface="Cambria" pitchFamily="34" charset="-120"/>
-              </a:rPr>
-              <a:t>The fix</a:t>
-            </a:r>
-            <a:endParaRPr lang="en-US" sz="1600" dirty="0"/>
-          </a:p>
-        </p:txBody>
-      </p:sp>
-      <p:sp>
-        <p:nvSpPr>
-          <p:cNvPr id="15" name="Text 13"/>
-          <p:cNvSpPr/>
-          <p:nvPr/>
-        </p:nvSpPr>
-        <p:spPr>
-          <a:xfrm>
-            <a:off x="8723376" y="3931920"/>
-            <a:ext cx="2971800" cy="1371600"/>
-          </a:xfrm>
-          <a:prstGeom prst="rect">
-            <a:avLst/>
-          </a:prstGeom>
-          <a:noFill/>
-          <a:ln/>
-        </p:spPr>
-        <p:txBody>
-          <a:bodyPr wrap="square" lIns="0" tIns="0" rIns="0" bIns="0" rtlCol="0" anchor="ctr"/>
-          <a:lstStyle/>
-          <a:p>
-            <a:pPr indent="0" marL="0">
-              <a:buNone/>
-            </a:pPr>
-            <a:r>
-              <a:rPr lang="en-US" sz="1300" dirty="0">
-                <a:solidFill>
-                  <a:srgbClr val="5A6B7A"/>
-                </a:solidFill>
-                <a:latin typeface="Calibri" pitchFamily="34" charset="0"/>
-                <a:ea typeface="Calibri" pitchFamily="34" charset="-122"/>
-                <a:cs typeface="Calibri" pitchFamily="34" charset="-120"/>
-              </a:rPr>
-              <a:t>Progressive disclosure. The short description stays in context; the body loads only when it matches the task.</a:t>
-            </a:r>
-            <a:endParaRPr lang="en-US" sz="1300" dirty="0"/>
+              <a:t>Drop every eval with a failed run: +22. Assume every lost run scored zero: +23. The honest headline is roughly +20 to +28 with a measurable over-firing cost.</a:t>
+            </a:r>
+            <a:endParaRPr lang="en-US" sz="1500" dirty="0"/>
           </a:p>
         </p:txBody>
       </p:sp>

</xml_diff>